<commit_message>
Boubacar seamless carousel: narrative hook on slides 1 to 3 (who he is, the worn-out land, the changed question)
Co-Authored-By: Claude Opus 5.5 <noreply@anthropic.com>
Claude-Session: https://claude.ai/code/session_014HGzAbxBh54nuyJHG7tse8
</commit_message>
<xml_diff>
--- a/templates/posts/october/01-10-2026-thu-ig-soil-regenerators-boubacar-panorama.pptx
+++ b/templates/posts/october/01-10-2026-thu-ig-soil-regenerators-boubacar-panorama.pptx
@@ -512,7 +512,7 @@
           <a:lstStyle/>
           <a:p>
             <a:r>
-              <a:t>Cover. Grid and continuous hyphae panorama after Stephanie's feedback. Background: assets/collage/boubacar-panorama/ (tools/make_hyphae_panorama.py, drawn by code). His quotes from his email to Allison, 30 Sep 2026. Call to action: his YouTube channel (his Instagram @tidia.diallo.1 is private). Sources: Impact story sheet, Boubacar Tidiane Diallo: https://docs.google.com/spreadsheets/d/10UHLwzJLBQAsmJqmg4hiCQRjBKXPAx7UnOudU-Vsg5U/edit; Email from Boubacar to Allison, 30 September 2026; Instagram: https://www.instagram.com/tidia.diallo.1/; YouTube: https://www.youtube.com/@boubacartidianediallo; Facebook: https://www.facebook.com/btidja; Photos: sent by Boubacar to Stephanie on WhatsApp, 17 August 2026, and to Allison, September 2026. [TAG @Stephanie] Send Boubacar the final caption and slides to approve before posting, and confirm he studied on a scholarship. Photo: boubacar-portrait-bananas-closer.jpg.</a:t>
+              <a:t>Cover. Grid and continuous hyphae panorama after Stephanie's feedback. Background: assets/collage/boubacar-panorama/ (tools/make_hyphae_panorama.py, drawn by code). His quotes from his email to Allison, 30 Sep 2026. Call to action: his YouTube channel (his Instagram @tidia.diallo.1 is private). Sources: Impact story sheet, Boubacar Tidiane Diallo: https://docs.google.com/spreadsheets/d/10UHLwzJLBQAsmJqmg4hiCQRjBKXPAx7UnOudU-Vsg5U/edit; Email from Boubacar to Allison, 30 September 2026; Instagram: https://www.instagram.com/tidia.diallo.1/; YouTube: https://www.youtube.com/@boubacartidianediallo; Facebook: https://www.facebook.com/btidja; Photos: sent by Boubacar to Stephanie on WhatsApp, 17 August 2026, and to Allison, September 2026. [TAG @Stephanie] Send Boubacar the final caption and slides to approve before posting, and confirm he studied on a scholarship. Photo: boubacar-portrait-bananas-closer.jpg. NEW COPY for approval (narrative hook): based on his email and the approved caption draft. Hook paraphrases his line 'Instead of simply feeding plants, I am learning to feed the soil ecosystem that supports the plants.'</a:t>
             </a:r>
           </a:p>
         </p:txBody>
@@ -722,7 +722,7 @@
           <a:lstStyle/>
           <a:p>
             <a:r>
-              <a:t>Gnaly. Grid and continuous hyphae panorama after Stephanie's feedback. Background: assets/collage/boubacar-panorama/ (tools/make_hyphae_panorama.py, drawn by code). His quotes from his email to Allison, 30 Sep 2026. Photos: farm-overview-with-tanks.jpeg, young-tree-with-pineapples.jpg, man-by-water-tanks.jpeg.</a:t>
+              <a:t>Gnaly. Grid and continuous hyphae panorama after Stephanie's feedback. Background: assets/collage/boubacar-panorama/ (tools/make_hyphae_panorama.py, drawn by code). His quotes from his email to Allison, 30 Sep 2026. Photos: farm-overview-with-tanks.jpeg, young-tree-with-pineapples.jpg, man-by-water-tanks.jpeg. NEW COPY for approval (narrative hook): based on his email and the approved caption draft. From the caption: 'When he started, the soil had been degraded and poorly managed for years.'</a:t>
             </a:r>
           </a:p>
         </p:txBody>
@@ -792,7 +792,7 @@
           <a:lstStyle/>
           <a:p>
             <a:r>
-              <a:t>The question. Grid and continuous hyphae panorama after Stephanie's feedback. Background: assets/collage/boubacar-panorama/ (tools/make_hyphae_panorama.py, drawn by code). His quotes from his email to Allison, 30 Sep 2026. Photo: vegetable-beds-by-building.jpeg.</a:t>
+              <a:t>The question. Grid and continuous hyphae panorama after Stephanie's feedback. Background: assets/collage/boubacar-panorama/ (tools/make_hyphae_panorama.py, drawn by code). His quotes from his email to Allison, 30 Sep 2026. Photo: vegetable-beds-by-building.jpeg. NEW COPY for approval (narrative hook): based on his email and the approved caption draft. Lead-in 'So he changed the question' is new; the quote is his.</a:t>
             </a:r>
           </a:p>
         </p:txBody>
@@ -4294,7 +4294,7 @@
       </p:sp>
       <p:pic>
         <p:nvPicPr>
-          <p:cNvPr id="4" name="Picture 3" descr="2915708506369299067.jpg"/>
+          <p:cNvPr id="4" name="Picture 3" descr="6542759857264025041.jpg"/>
           <p:cNvPicPr>
             <a:picLocks noChangeAspect="1"/>
           </p:cNvPicPr>
@@ -4471,8 +4471,8 @@
         </p:nvSpPr>
         <p:spPr>
           <a:xfrm>
-            <a:off x="1047750" y="8652408"/>
-            <a:ext cx="8191500" cy="1774962"/>
+            <a:off x="1047750" y="8681382"/>
+            <a:ext cx="8191500" cy="2024587"/>
           </a:xfrm>
           <a:prstGeom prst="rect">
             <a:avLst/>
@@ -4491,13 +4491,13 @@
               </a:lnSpc>
             </a:pPr>
             <a:r>
-              <a:rPr sz="5200" b="1" i="0">
+              <a:rPr sz="4000" b="1" i="0">
                 <a:solidFill>
                   <a:srgbClr val="1E1412"/>
                 </a:solidFill>
                 <a:latin typeface="Montserrat"/>
               </a:rPr>
-              <a:t>Boubacar Tidiane Diallo</a:t>
+              <a:t>Meet Boubacar. He grows coffee by feeding the soil, not just the plants.</a:t>
             </a:r>
           </a:p>
         </p:txBody>
@@ -4510,8 +4510,8 @@
         </p:nvSpPr>
         <p:spPr>
           <a:xfrm>
-            <a:off x="1047750" y="10427370"/>
-            <a:ext cx="8191500" cy="1017970"/>
+            <a:off x="1047750" y="10705969"/>
+            <a:ext cx="8191500" cy="710397"/>
           </a:xfrm>
           <a:prstGeom prst="rect">
             <a:avLst/>
@@ -4530,13 +4530,13 @@
               </a:lnSpc>
             </a:pPr>
             <a:r>
-              <a:rPr sz="5400" b="0" i="1">
+              <a:rPr sz="3600" b="0" i="0">
                 <a:solidFill>
                   <a:srgbClr val="1E1412"/>
                 </a:solidFill>
-                <a:latin typeface="EB Garamond"/>
+                <a:latin typeface="Source Sans 3"/>
               </a:rPr>
-              <a:t>Guinea-Conakry</a:t>
+              <a:t>Boubacar Tidiane Diallo, Guinea-Conakry</a:t>
             </a:r>
           </a:p>
         </p:txBody>
@@ -4635,7 +4635,7 @@
       </p:sp>
       <p:pic>
         <p:nvPicPr>
-          <p:cNvPr id="4" name="Picture 3" descr="1656793464594487231.jpg"/>
+          <p:cNvPr id="4" name="Picture 3" descr="859469730240263330.jpg"/>
           <p:cNvPicPr>
             <a:picLocks noChangeAspect="1"/>
           </p:cNvPicPr>
@@ -4709,7 +4709,7 @@
       </p:sp>
       <p:pic>
         <p:nvPicPr>
-          <p:cNvPr id="6" name="Picture 5" descr="2670209748706518420.jpg"/>
+          <p:cNvPr id="6" name="Picture 5" descr="6446222981120314919.jpg"/>
           <p:cNvPicPr>
             <a:picLocks noChangeAspect="1"/>
           </p:cNvPicPr>
@@ -4955,7 +4955,7 @@
       </p:sp>
       <p:pic>
         <p:nvPicPr>
-          <p:cNvPr id="4" name="Picture 3" descr="3569230909591733248.jpg"/>
+          <p:cNvPr id="4" name="Picture 3" descr="5882288245012575537.jpg"/>
           <p:cNvPicPr>
             <a:picLocks noChangeAspect="1"/>
           </p:cNvPicPr>
@@ -5264,7 +5264,7 @@
       </p:sp>
       <p:pic>
         <p:nvPicPr>
-          <p:cNvPr id="4" name="Picture 3" descr="4882987764756516542.jpg"/>
+          <p:cNvPr id="4" name="Picture 3" descr="888004338175241060.jpg"/>
           <p:cNvPicPr>
             <a:picLocks noChangeAspect="1"/>
           </p:cNvPicPr>
@@ -5338,7 +5338,7 @@
       </p:sp>
       <p:pic>
         <p:nvPicPr>
-          <p:cNvPr id="6" name="Picture 5" descr="5058600998190013377.jpg"/>
+          <p:cNvPr id="6" name="Picture 5" descr="2589091239255409415.jpg"/>
           <p:cNvPicPr>
             <a:picLocks noChangeAspect="1"/>
           </p:cNvPicPr>
@@ -5412,7 +5412,7 @@
       </p:sp>
       <p:pic>
         <p:nvPicPr>
-          <p:cNvPr id="8" name="Picture 7" descr="4463507082439028715.jpg"/>
+          <p:cNvPr id="8" name="Picture 7" descr="7450643337973146649.jpg"/>
           <p:cNvPicPr>
             <a:picLocks noChangeAspect="1"/>
           </p:cNvPicPr>
@@ -5494,8 +5494,8 @@
         </p:nvSpPr>
         <p:spPr>
           <a:xfrm>
-            <a:off x="1047750" y="8783164"/>
-            <a:ext cx="8191500" cy="1650149"/>
+            <a:off x="1047750" y="8625662"/>
+            <a:ext cx="8191500" cy="1213306"/>
           </a:xfrm>
           <a:prstGeom prst="rect">
             <a:avLst/>
@@ -5514,13 +5514,13 @@
               </a:lnSpc>
             </a:pPr>
             <a:r>
-              <a:rPr sz="4800" b="1" i="0">
+              <a:rPr sz="3400" b="1" i="0">
                 <a:solidFill>
                   <a:srgbClr val="22371F"/>
                 </a:solidFill>
                 <a:latin typeface="Montserrat"/>
               </a:rPr>
-              <a:t>Gnaly Coffee &amp; AgroÉcole Bio</a:t>
+              <a:t>When he started, the land was worn out.</a:t>
             </a:r>
           </a:p>
         </p:txBody>
@@ -5533,8 +5533,8 @@
         </p:nvSpPr>
         <p:spPr>
           <a:xfrm>
-            <a:off x="1047750" y="10433314"/>
-            <a:ext cx="8191500" cy="881271"/>
+            <a:off x="1047750" y="9838969"/>
+            <a:ext cx="8191500" cy="1633118"/>
           </a:xfrm>
           <a:prstGeom prst="rect">
             <a:avLst/>
@@ -5553,13 +5553,13 @@
               </a:lnSpc>
             </a:pPr>
             <a:r>
-              <a:rPr sz="4600" b="0" i="0">
+              <a:rPr sz="3000" b="0" i="0">
                 <a:solidFill>
                   <a:srgbClr val="22371F"/>
                 </a:solidFill>
                 <a:latin typeface="Source Sans 3"/>
               </a:rPr>
-              <a:t>Fouta Djallon, Guinea-Conakry</a:t>
+              <a:t>The soil at Gnaly Coffee &amp; AgroÉcole Bio, in the Fouta Djallon highlands of Guinea-Conakry, had been degraded and poorly managed for years.</a:t>
             </a:r>
           </a:p>
         </p:txBody>
@@ -5697,7 +5697,7 @@
       </p:sp>
       <p:pic>
         <p:nvPicPr>
-          <p:cNvPr id="4" name="Picture 3" descr="2432787470622474919.jpg"/>
+          <p:cNvPr id="4" name="Picture 3" descr="1053021958879629067.jpg"/>
           <p:cNvPicPr>
             <a:picLocks noChangeAspect="1"/>
           </p:cNvPicPr>
@@ -5818,8 +5818,47 @@
         </p:nvSpPr>
         <p:spPr>
           <a:xfrm>
-            <a:off x="1047750" y="8719693"/>
-            <a:ext cx="8191500" cy="2658363"/>
+            <a:off x="1047750" y="8948095"/>
+            <a:ext cx="8191500" cy="807665"/>
+          </a:xfrm>
+          <a:prstGeom prst="rect">
+            <a:avLst/>
+          </a:prstGeom>
+          <a:noFill/>
+        </p:spPr>
+        <p:txBody>
+          <a:bodyPr wrap="square" lIns="0" rIns="0" tIns="0" bIns="0" anchor="t">
+            <a:spAutoFit/>
+          </a:bodyPr>
+          <a:lstStyle/>
+          <a:p>
+            <a:pPr algn="l">
+              <a:lnSpc>
+                <a:spcPct val="105000"/>
+              </a:lnSpc>
+            </a:pPr>
+            <a:r>
+              <a:rPr sz="4200" b="1" i="0">
+                <a:solidFill>
+                  <a:srgbClr val="3A2524"/>
+                </a:solidFill>
+                <a:latin typeface="Montserrat"/>
+              </a:rPr>
+              <a:t>So he changed the question:</a:t>
+            </a:r>
+          </a:p>
+        </p:txBody>
+      </p:sp>
+      <p:sp>
+        <p:nvSpPr>
+          <p:cNvPr id="8" name="TextBox 7"/>
+          <p:cNvSpPr txBox="1"/>
+          <p:nvPr/>
+        </p:nvSpPr>
+        <p:spPr>
+          <a:xfrm>
+            <a:off x="1047750" y="9755760"/>
+            <a:ext cx="8191500" cy="1393894"/>
           </a:xfrm>
           <a:prstGeom prst="rect">
             <a:avLst/>
@@ -5838,7 +5877,7 @@
               </a:lnSpc>
             </a:pPr>
             <a:r>
-              <a:rPr sz="5000" b="0" i="1">
+              <a:rPr sz="3800" b="0" i="1">
                 <a:solidFill>
                   <a:srgbClr val="3A2524"/>
                 </a:solidFill>
@@ -5851,7 +5890,7 @@
       </p:sp>
       <p:sp>
         <p:nvSpPr>
-          <p:cNvPr id="8" name="TextBox 7"/>
+          <p:cNvPr id="9" name="TextBox 8"/>
           <p:cNvSpPr txBox="1"/>
           <p:nvPr/>
         </p:nvSpPr>
@@ -5982,7 +6021,7 @@
       </p:sp>
       <p:pic>
         <p:nvPicPr>
-          <p:cNvPr id="4" name="Picture 3" descr="2520087226536762781.jpg"/>
+          <p:cNvPr id="4" name="Picture 3" descr="3405020167820716295.jpg"/>
           <p:cNvPicPr>
             <a:picLocks noChangeAspect="1"/>
           </p:cNvPicPr>
@@ -6056,7 +6095,7 @@
       </p:sp>
       <p:pic>
         <p:nvPicPr>
-          <p:cNvPr id="6" name="Picture 5" descr="7727649350495454104.jpg"/>
+          <p:cNvPr id="6" name="Picture 5" descr="692908753897821274.jpg"/>
           <p:cNvPicPr>
             <a:picLocks noChangeAspect="1"/>
           </p:cNvPicPr>
@@ -6341,7 +6380,7 @@
       </p:sp>
       <p:pic>
         <p:nvPicPr>
-          <p:cNvPr id="4" name="Picture 3" descr="7360968692488919039.jpg"/>
+          <p:cNvPr id="4" name="Picture 3" descr="3489943308185391326.jpg"/>
           <p:cNvPicPr>
             <a:picLocks noChangeAspect="1"/>
           </p:cNvPicPr>
@@ -6415,7 +6454,7 @@
       </p:sp>
       <p:pic>
         <p:nvPicPr>
-          <p:cNvPr id="6" name="Picture 5" descr="8716839783421296724.jpg"/>
+          <p:cNvPr id="6" name="Picture 5" descr="8015735983394514869.jpg"/>
           <p:cNvPicPr>
             <a:picLocks noChangeAspect="1"/>
           </p:cNvPicPr>
@@ -6489,7 +6528,7 @@
       </p:sp>
       <p:pic>
         <p:nvPicPr>
-          <p:cNvPr id="8" name="Picture 7" descr="3409816208287969392.jpg"/>
+          <p:cNvPr id="8" name="Picture 7" descr="290664270133015781.jpg"/>
           <p:cNvPicPr>
             <a:picLocks noChangeAspect="1"/>
           </p:cNvPicPr>
@@ -6735,7 +6774,7 @@
       </p:sp>
       <p:pic>
         <p:nvPicPr>
-          <p:cNvPr id="4" name="Picture 3" descr="5476898924618735149.jpg"/>
+          <p:cNvPr id="4" name="Picture 3" descr="1388158669510424059.jpg"/>
           <p:cNvPicPr>
             <a:picLocks noChangeAspect="1"/>
           </p:cNvPicPr>
@@ -6809,7 +6848,7 @@
       </p:sp>
       <p:pic>
         <p:nvPicPr>
-          <p:cNvPr id="6" name="Picture 5" descr="7536453492721166001.jpg"/>
+          <p:cNvPr id="6" name="Picture 5" descr="1833522976654264346.jpg"/>
           <p:cNvPicPr>
             <a:picLocks noChangeAspect="1"/>
           </p:cNvPicPr>
@@ -7094,7 +7133,7 @@
       </p:sp>
       <p:pic>
         <p:nvPicPr>
-          <p:cNvPr id="4" name="Picture 3" descr="6419506637691987574.jpg"/>
+          <p:cNvPr id="4" name="Picture 3" descr="789572690591433854.jpg"/>
           <p:cNvPicPr>
             <a:picLocks noChangeAspect="1"/>
           </p:cNvPicPr>
@@ -7168,7 +7207,7 @@
       </p:sp>
       <p:pic>
         <p:nvPicPr>
-          <p:cNvPr id="6" name="Picture 5" descr="6794266426832732997.jpg"/>
+          <p:cNvPr id="6" name="Picture 5" descr="3937504228287124507.jpg"/>
           <p:cNvPicPr>
             <a:picLocks noChangeAspect="1"/>
           </p:cNvPicPr>
@@ -7242,7 +7281,7 @@
       </p:sp>
       <p:pic>
         <p:nvPicPr>
-          <p:cNvPr id="8" name="Picture 7" descr="2208559977968711287.jpg"/>
+          <p:cNvPr id="8" name="Picture 7" descr="2074871535571420541.jpg"/>
           <p:cNvPicPr>
             <a:picLocks noChangeAspect="1"/>
           </p:cNvPicPr>
@@ -7488,7 +7527,7 @@
       </p:sp>
       <p:pic>
         <p:nvPicPr>
-          <p:cNvPr id="4" name="Picture 3" descr="2674830737729816644.jpg"/>
+          <p:cNvPr id="4" name="Picture 3" descr="637867189905250528.jpg"/>
           <p:cNvPicPr>
             <a:picLocks noChangeAspect="1"/>
           </p:cNvPicPr>
@@ -7562,7 +7601,7 @@
       </p:sp>
       <p:pic>
         <p:nvPicPr>
-          <p:cNvPr id="6" name="Picture 5" descr="5132770453172844333.jpg"/>
+          <p:cNvPr id="6" name="Picture 5" descr="960496982117691770.jpg"/>
           <p:cNvPicPr>
             <a:picLocks noChangeAspect="1"/>
           </p:cNvPicPr>
@@ -7847,7 +7886,7 @@
       </p:sp>
       <p:pic>
         <p:nvPicPr>
-          <p:cNvPr id="4" name="Picture 3" descr="6370427101001267727.jpg"/>
+          <p:cNvPr id="4" name="Picture 3" descr="1472895862002148508.jpg"/>
           <p:cNvPicPr>
             <a:picLocks noChangeAspect="1"/>
           </p:cNvPicPr>
@@ -7921,7 +7960,7 @@
       </p:sp>
       <p:pic>
         <p:nvPicPr>
-          <p:cNvPr id="6" name="Picture 5" descr="8487187208040710867.jpg"/>
+          <p:cNvPr id="6" name="Picture 5" descr="2691755101342095090.jpg"/>
           <p:cNvPicPr>
             <a:picLocks noChangeAspect="1"/>
           </p:cNvPicPr>
@@ -7995,7 +8034,7 @@
       </p:sp>
       <p:pic>
         <p:nvPicPr>
-          <p:cNvPr id="8" name="Picture 7" descr="4732268557193302030.jpg"/>
+          <p:cNvPr id="8" name="Picture 7" descr="8962696689160125669.jpg"/>
           <p:cNvPicPr>
             <a:picLocks noChangeAspect="1"/>
           </p:cNvPicPr>

</xml_diff>

<commit_message>
Boubacar seamless carousel: cover back to name and place, plus graduation line (July 2026)
Co-Authored-By: Claude Opus 5.5 <noreply@anthropic.com>
Claude-Session: https://claude.ai/code/session_014HGzAbxBh54nuyJHG7tse8
</commit_message>
<xml_diff>
--- a/templates/posts/october/01-10-2026-thu-ig-soil-regenerators-boubacar-panorama.pptx
+++ b/templates/posts/october/01-10-2026-thu-ig-soil-regenerators-boubacar-panorama.pptx
@@ -512,7 +512,7 @@
           <a:lstStyle/>
           <a:p>
             <a:r>
-              <a:t>Cover. Grid and continuous hyphae panorama after Stephanie's feedback. Background: assets/collage/boubacar-panorama/ (tools/make_hyphae_panorama.py, drawn by code). His quotes from his email to Allison, 30 Sep 2026. Call to action: his YouTube channel (his Instagram @tidia.diallo.1 is private). Sources: Impact story sheet, Boubacar Tidiane Diallo: https://docs.google.com/spreadsheets/d/10UHLwzJLBQAsmJqmg4hiCQRjBKXPAx7UnOudU-Vsg5U/edit; Email from Boubacar to Allison, 30 September 2026; Instagram: https://www.instagram.com/tidia.diallo.1/; YouTube: https://www.youtube.com/@boubacartidianediallo; Facebook: https://www.facebook.com/btidja; Photos: sent by Boubacar to Stephanie on WhatsApp, 17 August 2026, and to Allison, September 2026. [TAG @Stephanie] Send Boubacar the final caption and slides to approve before posting, and confirm he studied on a scholarship. Photo: boubacar-portrait-bananas-closer.jpg. NEW COPY for approval (narrative hook): based on his email and the approved caption draft. Hook paraphrases his line 'Instead of simply feeding plants, I am learning to feed the soil ecosystem that supports the plants.'</a:t>
+              <a:t>Cover. Grid and continuous hyphae panorama after Stephanie's feedback. Background: assets/collage/boubacar-panorama/ (tools/make_hyphae_panorama.py, drawn by code). His quotes from his email to Allison, 30 Sep 2026. Call to action: his YouTube channel (his Instagram @tidia.diallo.1 is private). Sources: Impact story sheet, Boubacar Tidiane Diallo: https://docs.google.com/spreadsheets/d/10UHLwzJLBQAsmJqmg4hiCQRjBKXPAx7UnOudU-Vsg5U/edit; Email from Boubacar to Allison, 30 September 2026; Instagram: https://www.instagram.com/tidia.diallo.1/; YouTube: https://www.youtube.com/@boubacartidianediallo; Facebook: https://www.facebook.com/btidja; Photos: sent by Boubacar to Stephanie on WhatsApp, 17 August 2026, and to Allison, September 2026. [TAG @Stephanie] Send Boubacar the final caption and slides to approve before posting, and confirm he studied on a scholarship. Photo: boubacar-portrait-bananas-closer.jpg. Graduation line from Linnea (1 Oct 2026): confirm the exact course or program and the date [VERIFY].</a:t>
             </a:r>
           </a:p>
         </p:txBody>
@@ -4294,7 +4294,7 @@
       </p:sp>
       <p:pic>
         <p:nvPicPr>
-          <p:cNvPr id="4" name="Picture 3" descr="6542759857264025041.jpg"/>
+          <p:cNvPr id="4" name="Picture 3" descr="7134253713308919662.jpg"/>
           <p:cNvPicPr>
             <a:picLocks noChangeAspect="1"/>
           </p:cNvPicPr>
@@ -4471,8 +4471,8 @@
         </p:nvSpPr>
         <p:spPr>
           <a:xfrm>
-            <a:off x="1047750" y="8681382"/>
-            <a:ext cx="8191500" cy="2024587"/>
+            <a:off x="1047750" y="8623434"/>
+            <a:ext cx="8191500" cy="807665"/>
           </a:xfrm>
           <a:prstGeom prst="rect">
             <a:avLst/>
@@ -4491,13 +4491,13 @@
               </a:lnSpc>
             </a:pPr>
             <a:r>
-              <a:rPr sz="4000" b="1" i="0">
+              <a:rPr sz="4200" b="1" i="0">
                 <a:solidFill>
                   <a:srgbClr val="1E1412"/>
                 </a:solidFill>
                 <a:latin typeface="Montserrat"/>
               </a:rPr>
-              <a:t>Meet Boubacar. He grows coffee by feeding the soil, not just the plants.</a:t>
+              <a:t>Boubacar Tidiane Diallo</a:t>
             </a:r>
           </a:p>
         </p:txBody>
@@ -4510,8 +4510,8 @@
         </p:nvSpPr>
         <p:spPr>
           <a:xfrm>
-            <a:off x="1047750" y="10705969"/>
-            <a:ext cx="8191500" cy="710397"/>
+            <a:off x="1047750" y="9431099"/>
+            <a:ext cx="8191500" cy="2043216"/>
           </a:xfrm>
           <a:prstGeom prst="rect">
             <a:avLst/>
@@ -4530,13 +4530,29 @@
               </a:lnSpc>
             </a:pPr>
             <a:r>
-              <a:rPr sz="3600" b="0" i="0">
+              <a:rPr sz="3800" b="0" i="0">
                 <a:solidFill>
                   <a:srgbClr val="1E1412"/>
                 </a:solidFill>
                 <a:latin typeface="Source Sans 3"/>
               </a:rPr>
-              <a:t>Boubacar Tidiane Diallo, Guinea-Conakry</a:t>
+              <a:t>Guinea-Conakry</a:t>
+            </a:r>
+          </a:p>
+          <a:p>
+            <a:pPr algn="l">
+              <a:lnSpc>
+                <a:spcPct val="115000"/>
+              </a:lnSpc>
+            </a:pPr>
+            <a:r>
+              <a:rPr sz="3800" b="0" i="0">
+                <a:solidFill>
+                  <a:srgbClr val="1E1412"/>
+                </a:solidFill>
+                <a:latin typeface="Source Sans 3"/>
+              </a:rPr>
+              <a:t>Graduated from the Soil Food Web School in July 2026</a:t>
             </a:r>
           </a:p>
         </p:txBody>
@@ -4635,7 +4651,7 @@
       </p:sp>
       <p:pic>
         <p:nvPicPr>
-          <p:cNvPr id="4" name="Picture 3" descr="859469730240263330.jpg"/>
+          <p:cNvPr id="4" name="Picture 3" descr="5624748979687717632.jpg"/>
           <p:cNvPicPr>
             <a:picLocks noChangeAspect="1"/>
           </p:cNvPicPr>
@@ -4709,7 +4725,7 @@
       </p:sp>
       <p:pic>
         <p:nvPicPr>
-          <p:cNvPr id="6" name="Picture 5" descr="6446222981120314919.jpg"/>
+          <p:cNvPr id="6" name="Picture 5" descr="5312846024647597565.jpg"/>
           <p:cNvPicPr>
             <a:picLocks noChangeAspect="1"/>
           </p:cNvPicPr>
@@ -4955,7 +4971,7 @@
       </p:sp>
       <p:pic>
         <p:nvPicPr>
-          <p:cNvPr id="4" name="Picture 3" descr="5882288245012575537.jpg"/>
+          <p:cNvPr id="4" name="Picture 3" descr="1198194770462467164.jpg"/>
           <p:cNvPicPr>
             <a:picLocks noChangeAspect="1"/>
           </p:cNvPicPr>
@@ -5264,7 +5280,7 @@
       </p:sp>
       <p:pic>
         <p:nvPicPr>
-          <p:cNvPr id="4" name="Picture 3" descr="888004338175241060.jpg"/>
+          <p:cNvPr id="4" name="Picture 3" descr="6418962251702900842.jpg"/>
           <p:cNvPicPr>
             <a:picLocks noChangeAspect="1"/>
           </p:cNvPicPr>
@@ -5338,7 +5354,7 @@
       </p:sp>
       <p:pic>
         <p:nvPicPr>
-          <p:cNvPr id="6" name="Picture 5" descr="2589091239255409415.jpg"/>
+          <p:cNvPr id="6" name="Picture 5" descr="6699318444570406175.jpg"/>
           <p:cNvPicPr>
             <a:picLocks noChangeAspect="1"/>
           </p:cNvPicPr>
@@ -5412,7 +5428,7 @@
       </p:sp>
       <p:pic>
         <p:nvPicPr>
-          <p:cNvPr id="8" name="Picture 7" descr="7450643337973146649.jpg"/>
+          <p:cNvPr id="8" name="Picture 7" descr="8653640377674119268.jpg"/>
           <p:cNvPicPr>
             <a:picLocks noChangeAspect="1"/>
           </p:cNvPicPr>
@@ -5697,7 +5713,7 @@
       </p:sp>
       <p:pic>
         <p:nvPicPr>
-          <p:cNvPr id="4" name="Picture 3" descr="1053021958879629067.jpg"/>
+          <p:cNvPr id="4" name="Picture 3" descr="5288047924582150184.jpg"/>
           <p:cNvPicPr>
             <a:picLocks noChangeAspect="1"/>
           </p:cNvPicPr>
@@ -6021,7 +6037,7 @@
       </p:sp>
       <p:pic>
         <p:nvPicPr>
-          <p:cNvPr id="4" name="Picture 3" descr="3405020167820716295.jpg"/>
+          <p:cNvPr id="4" name="Picture 3" descr="8041883124578728280.jpg"/>
           <p:cNvPicPr>
             <a:picLocks noChangeAspect="1"/>
           </p:cNvPicPr>
@@ -6095,7 +6111,7 @@
       </p:sp>
       <p:pic>
         <p:nvPicPr>
-          <p:cNvPr id="6" name="Picture 5" descr="692908753897821274.jpg"/>
+          <p:cNvPr id="6" name="Picture 5" descr="5109255838637421891.jpg"/>
           <p:cNvPicPr>
             <a:picLocks noChangeAspect="1"/>
           </p:cNvPicPr>
@@ -6380,7 +6396,7 @@
       </p:sp>
       <p:pic>
         <p:nvPicPr>
-          <p:cNvPr id="4" name="Picture 3" descr="3489943308185391326.jpg"/>
+          <p:cNvPr id="4" name="Picture 3" descr="7845958211265690100.jpg"/>
           <p:cNvPicPr>
             <a:picLocks noChangeAspect="1"/>
           </p:cNvPicPr>
@@ -6454,7 +6470,7 @@
       </p:sp>
       <p:pic>
         <p:nvPicPr>
-          <p:cNvPr id="6" name="Picture 5" descr="8015735983394514869.jpg"/>
+          <p:cNvPr id="6" name="Picture 5" descr="6768793353179528146.jpg"/>
           <p:cNvPicPr>
             <a:picLocks noChangeAspect="1"/>
           </p:cNvPicPr>
@@ -6528,7 +6544,7 @@
       </p:sp>
       <p:pic>
         <p:nvPicPr>
-          <p:cNvPr id="8" name="Picture 7" descr="290664270133015781.jpg"/>
+          <p:cNvPr id="8" name="Picture 7" descr="502298545864334185.jpg"/>
           <p:cNvPicPr>
             <a:picLocks noChangeAspect="1"/>
           </p:cNvPicPr>
@@ -6774,7 +6790,7 @@
       </p:sp>
       <p:pic>
         <p:nvPicPr>
-          <p:cNvPr id="4" name="Picture 3" descr="1388158669510424059.jpg"/>
+          <p:cNvPr id="4" name="Picture 3" descr="5578419962022039927.jpg"/>
           <p:cNvPicPr>
             <a:picLocks noChangeAspect="1"/>
           </p:cNvPicPr>
@@ -6848,7 +6864,7 @@
       </p:sp>
       <p:pic>
         <p:nvPicPr>
-          <p:cNvPr id="6" name="Picture 5" descr="1833522976654264346.jpg"/>
+          <p:cNvPr id="6" name="Picture 5" descr="885020190814030041.jpg"/>
           <p:cNvPicPr>
             <a:picLocks noChangeAspect="1"/>
           </p:cNvPicPr>
@@ -7133,7 +7149,7 @@
       </p:sp>
       <p:pic>
         <p:nvPicPr>
-          <p:cNvPr id="4" name="Picture 3" descr="789572690591433854.jpg"/>
+          <p:cNvPr id="4" name="Picture 3" descr="2653324706775147677.jpg"/>
           <p:cNvPicPr>
             <a:picLocks noChangeAspect="1"/>
           </p:cNvPicPr>
@@ -7207,7 +7223,7 @@
       </p:sp>
       <p:pic>
         <p:nvPicPr>
-          <p:cNvPr id="6" name="Picture 5" descr="3937504228287124507.jpg"/>
+          <p:cNvPr id="6" name="Picture 5" descr="2791720370428551117.jpg"/>
           <p:cNvPicPr>
             <a:picLocks noChangeAspect="1"/>
           </p:cNvPicPr>
@@ -7281,7 +7297,7 @@
       </p:sp>
       <p:pic>
         <p:nvPicPr>
-          <p:cNvPr id="8" name="Picture 7" descr="2074871535571420541.jpg"/>
+          <p:cNvPr id="8" name="Picture 7" descr="8985887862467248455.jpg"/>
           <p:cNvPicPr>
             <a:picLocks noChangeAspect="1"/>
           </p:cNvPicPr>
@@ -7527,7 +7543,7 @@
       </p:sp>
       <p:pic>
         <p:nvPicPr>
-          <p:cNvPr id="4" name="Picture 3" descr="637867189905250528.jpg"/>
+          <p:cNvPr id="4" name="Picture 3" descr="2576760445911522804.jpg"/>
           <p:cNvPicPr>
             <a:picLocks noChangeAspect="1"/>
           </p:cNvPicPr>
@@ -7601,7 +7617,7 @@
       </p:sp>
       <p:pic>
         <p:nvPicPr>
-          <p:cNvPr id="6" name="Picture 5" descr="960496982117691770.jpg"/>
+          <p:cNvPr id="6" name="Picture 5" descr="5796296351949293045.jpg"/>
           <p:cNvPicPr>
             <a:picLocks noChangeAspect="1"/>
           </p:cNvPicPr>
@@ -7886,7 +7902,7 @@
       </p:sp>
       <p:pic>
         <p:nvPicPr>
-          <p:cNvPr id="4" name="Picture 3" descr="1472895862002148508.jpg"/>
+          <p:cNvPr id="4" name="Picture 3" descr="7569565634467311940.jpg"/>
           <p:cNvPicPr>
             <a:picLocks noChangeAspect="1"/>
           </p:cNvPicPr>
@@ -7960,7 +7976,7 @@
       </p:sp>
       <p:pic>
         <p:nvPicPr>
-          <p:cNvPr id="6" name="Picture 5" descr="2691755101342095090.jpg"/>
+          <p:cNvPr id="6" name="Picture 5" descr="2243472078506660866.jpg"/>
           <p:cNvPicPr>
             <a:picLocks noChangeAspect="1"/>
           </p:cNvPicPr>
@@ -8034,7 +8050,7 @@
       </p:sp>
       <p:pic>
         <p:nvPicPr>
-          <p:cNvPr id="8" name="Picture 7" descr="8962696689160125669.jpg"/>
+          <p:cNvPr id="8" name="Picture 7" descr="4989919598133606109.jpg"/>
           <p:cNvPicPr>
             <a:picLocks noChangeAspect="1"/>
           </p:cNvPicPr>

</xml_diff>